<commit_message>
Widen Master/Slave fault-flow diagrams for legibility
Switch master_fault_flow and slave_halt_flow mermaid diagrams from
vertical to horizontal layout with larger font, and update the pptx
build script to lay out these wide diagrams below the bullet text.

Co-Authored-By: Claude Sonnet 4.6 <noreply@anthropic.com>
Claude-Session: https://claude.ai/code/session_01UcZX9gdfC56CAidpRSm7mN
</commit_message>
<xml_diff>
--- a/section3_part2_internals.pptx
+++ b/section3_part2_internals.pptx
@@ -3755,8 +3755,8 @@
         </p:nvSpPr>
         <p:spPr>
           <a:xfrm>
-            <a:off x="548640" y="1234440"/>
-            <a:ext cx="3383280" cy="2971800"/>
+            <a:off x="548640" y="1188720"/>
+            <a:ext cx="8046720" cy="685800"/>
           </a:xfrm>
           <a:prstGeom prst="rect">
             <a:avLst/>
@@ -3770,7 +3770,7 @@
           <a:p>
             <a:pPr marL="342900" indent="-342900">
               <a:spcAft>
-                <a:spcPts val="800"/>
+                <a:spcPts val="600"/>
               </a:spcAft>
               <a:buSzPct val="100000"/>
               <a:buChar char="•"/>
@@ -3791,7 +3791,7 @@
           <a:p>
             <a:pPr marL="342900" indent="-342900">
               <a:spcAft>
-                <a:spcPts val="800"/>
+                <a:spcPts val="600"/>
               </a:spcAft>
               <a:buSzPct val="100000"/>
               <a:buChar char="•"/>
@@ -3812,7 +3812,7 @@
           <a:p>
             <a:pPr marL="342900" indent="-342900">
               <a:spcAft>
-                <a:spcPts val="800"/>
+                <a:spcPts val="600"/>
               </a:spcAft>
               <a:buSzPct val="100000"/>
               <a:buChar char="•"/>
@@ -3833,7 +3833,7 @@
           <a:p>
             <a:pPr marL="342900" indent="-342900">
               <a:spcAft>
-                <a:spcPts val="800"/>
+                <a:spcPts val="600"/>
               </a:spcAft>
               <a:buSzPct val="100000"/>
               <a:buChar char="•"/>
@@ -3868,8 +3868,8 @@
         </p:blipFill>
         <p:spPr>
           <a:xfrm>
-            <a:off x="5843658" y="1097280"/>
-            <a:ext cx="1205725" cy="3200400"/>
+            <a:off x="548640" y="2404499"/>
+            <a:ext cx="8046720" cy="1683242"/>
           </a:xfrm>
           <a:prstGeom prst="rect">
             <a:avLst/>
@@ -4175,8 +4175,8 @@
         </p:nvSpPr>
         <p:spPr>
           <a:xfrm>
-            <a:off x="548640" y="1234440"/>
-            <a:ext cx="3383280" cy="2971800"/>
+            <a:off x="548640" y="1188720"/>
+            <a:ext cx="8046720" cy="685800"/>
           </a:xfrm>
           <a:prstGeom prst="rect">
             <a:avLst/>
@@ -4190,7 +4190,7 @@
           <a:p>
             <a:pPr marL="342900" indent="-342900">
               <a:spcAft>
-                <a:spcPts val="800"/>
+                <a:spcPts val="600"/>
               </a:spcAft>
               <a:buSzPct val="100000"/>
               <a:buChar char="•"/>
@@ -4211,7 +4211,7 @@
           <a:p>
             <a:pPr marL="342900" indent="-342900">
               <a:spcAft>
-                <a:spcPts val="800"/>
+                <a:spcPts val="600"/>
               </a:spcAft>
               <a:buSzPct val="100000"/>
               <a:buChar char="•"/>
@@ -4232,7 +4232,7 @@
           <a:p>
             <a:pPr marL="342900" indent="-342900">
               <a:spcAft>
-                <a:spcPts val="800"/>
+                <a:spcPts val="600"/>
               </a:spcAft>
               <a:buSzPct val="100000"/>
               <a:buChar char="•"/>
@@ -4253,7 +4253,7 @@
           <a:p>
             <a:pPr marL="342900" indent="-342900">
               <a:spcAft>
-                <a:spcPts val="800"/>
+                <a:spcPts val="600"/>
               </a:spcAft>
               <a:buSzPct val="100000"/>
               <a:buChar char="•"/>
@@ -4288,8 +4288,8 @@
         </p:blipFill>
         <p:spPr>
           <a:xfrm>
-            <a:off x="6008052" y="1097280"/>
-            <a:ext cx="876936" cy="3200400"/>
+            <a:off x="548640" y="2291598"/>
+            <a:ext cx="8046720" cy="1909043"/>
           </a:xfrm>
           <a:prstGeom prst="rect">
             <a:avLst/>

</xml_diff>

<commit_message>
Fold in user's text simplifications on slides 3, 4, 7
Drop the frame-structure detail and asymmetric clock formula, and
trim the slave fault-handling wording to match the user's own edits,
so the build script stays the canonical source for this deck.

Co-Authored-By: Claude Sonnet 4.6 <noreply@anthropic.com>
Claude-Session: https://claude.ai/code/session_01UcZX9gdfC56CAidpRSm7mN
</commit_message>
<xml_diff>
--- a/section3_part2_internals.pptx
+++ b/section3_part2_internals.pptx
@@ -1943,7 +1943,7 @@
                 <a:ea typeface="Noto Sans CJK KR" pitchFamily="34" charset="-122"/>
                 <a:cs typeface="Noto Sans CJK KR" pitchFamily="34" charset="-120"/>
               </a:rPr>
-              <a:t>버튼의 디바운스된 단발 펄스마다 슬롯별로 정해진 값만큼 증가</a:t>
+              <a:t>버튼을 누를 때마다 슬롯별로 정해진 값만큼 증가</a:t>
             </a:r>
             <a:endParaRPr lang="en-US" sz="1800" dirty="0"/>
           </a:p>
@@ -3195,45 +3195,6 @@
         </p:nvSpPr>
         <p:spPr>
           <a:xfrm>
-            <a:off x="548640" y="3383280"/>
-            <a:ext cx="8046720" cy="640080"/>
-          </a:xfrm>
-          <a:prstGeom prst="rect">
-            <a:avLst/>
-          </a:prstGeom>
-          <a:noFill/>
-          <a:ln/>
-        </p:spPr>
-        <p:txBody>
-          <a:bodyPr wrap="square" rtlCol="0" anchor="t"/>
-          <a:lstStyle/>
-          <a:p>
-            <a:pPr indent="0" marL="0">
-              <a:buNone/>
-            </a:pPr>
-            <a:r>
-              <a:rPr lang="en-US" sz="1600" dirty="0">
-                <a:solidFill>
-                  <a:srgbClr val="444444"/>
-                </a:solidFill>
-                <a:latin typeface="Noto Sans CJK KR" pitchFamily="34" charset="0"/>
-                <a:ea typeface="Noto Sans CJK KR" pitchFamily="34" charset="-122"/>
-                <a:cs typeface="Noto Sans CJK KR" pitchFamily="34" charset="-120"/>
-              </a:rPr>
-              <a:t>32비트 payload는 프레임 내부에서 {slot_id(3bit) + payload(32bit)}로 결합된 뒤 Hamming 인코딩되어 50비트 프레임으로 전송됨</a:t>
-            </a:r>
-            <a:endParaRPr lang="en-US" sz="1600" dirty="0"/>
-          </a:p>
-        </p:txBody>
-      </p:sp>
-      <p:sp>
-        <p:nvSpPr>
-          <p:cNvPr id="6" name="Text 3"/>
-          <p:cNvSpPr/>
-          <p:nvPr/>
-        </p:nvSpPr>
-        <p:spPr>
-          <a:xfrm>
             <a:off x="8503920" y="4754880"/>
             <a:ext cx="457200" cy="274320"/>
           </a:xfrm>
@@ -3408,7 +3369,7 @@
                 <a:ea typeface="Noto Sans CJK KR" pitchFamily="34" charset="-122"/>
                 <a:cs typeface="Noto Sans CJK KR" pitchFamily="34" charset="-120"/>
               </a:rPr>
-              <a:t>분주된 비트 구간은 Master가 DIV 클럭, Slave가 (DIV+1) 클럭으로 1클럭만큼 비대칭 — 동일 DIV를 가정해도 실제 주파수는 정확히 같지 않음</a:t>
+              <a:t>분주 클럭은 메인 클럭 / (DIV + 1)</a:t>
             </a:r>
             <a:endParaRPr lang="en-US" sz="2000" dirty="0"/>
           </a:p>
@@ -4016,7 +3977,7 @@
                 <a:ea typeface="Noto Sans CJK KR" pitchFamily="34" charset="-122"/>
                 <a:cs typeface="Noto Sans CJK KR" pitchFamily="34" charset="-120"/>
               </a:rPr>
-              <a:t>Master broadcast 프레임의 halt_cmd(halt_mask) 필드를 수신하면 해당 슬롯을 active_slot에서 제외 → 그 슬롯의 TX가 발행되지 않음</a:t>
+              <a:t>Master broadcast 프레임의 halt_cmd(halt_mask) 필드를 수신하면 해당 슬롯은 송신 중단</a:t>
             </a:r>
             <a:endParaRPr lang="en-US" sz="2000" dirty="0"/>
           </a:p>
@@ -4037,7 +3998,7 @@
                 <a:ea typeface="Noto Sans CJK KR" pitchFamily="34" charset="-122"/>
                 <a:cs typeface="Noto Sans CJK KR" pitchFamily="34" charset="-120"/>
               </a:rPr>
-              <a:t>Master가 다음 broadcast에서 해당 비트를 0으로 보내면 다음 사이클부터 자동으로 재개 — Slave 쪽에서 재시작을 요청하는 로직은 없음</a:t>
+              <a:t>Master가 다음 broadcast에서 해당 비트를 0으로 보내면 다음 사이클부터 자동으로 재개</a:t>
             </a:r>
             <a:endParaRPr lang="en-US" sz="2000" dirty="0"/>
           </a:p>
@@ -4058,7 +4019,7 @@
                 <a:ea typeface="Noto Sans CJK KR" pitchFamily="34" charset="-122"/>
                 <a:cs typeface="Noto Sans CJK KR" pitchFamily="34" charset="-120"/>
               </a:rPr>
-              <a:t>Slave 자체 감지 고장(tx_overlap, slot_timing_invalid, pl_payload6/7_invalid, rx_ham_2bit)은 sticky 플래그로 누적되어 PS에 인터럽트만 발생, 자동 셧다운은 하지 않음</a:t>
+              <a:t>Slave 자체 감지 고장(tx_overlap, slot_timing_invalid, pl_payload6/7_invalid, rx_ham_2bit)은 플래그로 누적되어 인터럽트 신호만 발생, 별도 조치는 없음</a:t>
             </a:r>
             <a:endParaRPr lang="en-US" sz="2000" dirty="0"/>
           </a:p>

</xml_diff>

<commit_message>
Remove Slave halt flow diagram slide per user edit
User dropped the slide entirely; update the build script to match
so it stays the canonical source for future regenerations.

Co-Authored-By: Claude Sonnet 4.6 <noreply@anthropic.com>
Claude-Session: https://claude.ai/code/session_01UcZX9gdfC56CAidpRSm7mN
</commit_message>
<xml_diff>
--- a/section3_part2_internals.pptx
+++ b/section3_part2_internals.pptx
@@ -4,6 +4,9 @@
   <p:sldMasterIdLst>
     <p:sldMasterId id="2147483648" r:id="rId1"/>
   </p:sldMasterIdLst>
+  <p:notesMasterIdLst>
+    <p:notesMasterId r:id="rId9"/>
+  </p:notesMasterIdLst>
   <p:sldIdLst>
     <p:sldId id="256" r:id="rId2"/>
     <p:sldId id="257" r:id="rId3"/>
@@ -12,12 +15,8 @@
     <p:sldId id="260" r:id="rId6"/>
     <p:sldId id="261" r:id="rId7"/>
     <p:sldId id="262" r:id="rId8"/>
-    <p:sldId id="263" r:id="rId9"/>
   </p:sldIdLst>
-  <p:notesMasterIdLst>
-    <p:notesMasterId r:id="rId10"/>
-  </p:notesMasterIdLst>
-  <p:sldSz cx="9144000" cy="5143500"/>
+  <p:sldSz cx="9144000" cy="5143500" type="screen16x9"/>
   <p:notesSz cx="5143500" cy="9144000"/>
   <p:defaultTextStyle>
     <a:lvl1pPr marL="0" algn="l" defTabSz="914400" rtl="0" eaLnBrk="1" latinLnBrk="0" hangingPunct="1">
@@ -111,6 +110,11 @@
       </a:defRPr>
     </a:lvl9pPr>
   </p:defaultTextStyle>
+  <p:extLst>
+    <p:ext uri="{EFAFB233-063F-42B5-8137-9DF3F51BA10A}">
+      <p15:sldGuideLst xmlns:p15="http://schemas.microsoft.com/office/powerpoint/2012/main"/>
+    </p:ext>
+  </p:extLst>
 </p:presentation>
 </file>
 
@@ -136,240 +140,16 @@
           <a:chExt cx="0" cy="0"/>
         </a:xfrm>
       </p:grpSpPr>
-      <p:sp>
-        <p:nvSpPr>
-          <p:cNvPr id="2" name="Header Placeholder 1"/>
-          <p:cNvSpPr>
-            <a:spLocks noGrp="1"/>
-          </p:cNvSpPr>
-          <p:nvPr>
-            <p:ph type="hdr" sz="quarter"/>
-          </p:nvPr>
-        </p:nvSpPr>
-        <p:spPr>
-          <a:xfrm>
-            <a:off x="0" y="0"/>
-            <a:ext cx="2971800" cy="458788"/>
-          </a:xfrm>
-          <a:prstGeom prst="rect">
-            <a:avLst/>
-          </a:prstGeom>
-        </p:spPr>
-        <p:txBody>
-          <a:bodyPr vert="horz" lIns="91440" tIns="45720" rIns="91440" bIns="45720" rtlCol="0"/>
-          <a:lstStyle>
-            <a:lvl1pPr algn="l">
-              <a:defRPr sz="1200"/>
-            </a:lvl1pPr>
-          </a:lstStyle>
-          <a:p>
-            <a:endParaRPr lang="en-US"/>
-          </a:p>
-        </p:txBody>
-      </p:sp>
-      <p:sp>
-        <p:nvSpPr>
-          <p:cNvPr id="3" name="Date Placeholder 2"/>
-          <p:cNvSpPr>
-            <a:spLocks noGrp="1"/>
-          </p:cNvSpPr>
-          <p:nvPr>
-            <p:ph type="dt" idx="1"/>
-          </p:nvPr>
-        </p:nvSpPr>
-        <p:spPr>
-          <a:xfrm>
-            <a:off x="3884613" y="0"/>
-            <a:ext cx="2971800" cy="458788"/>
-          </a:xfrm>
-          <a:prstGeom prst="rect">
-            <a:avLst/>
-          </a:prstGeom>
-        </p:spPr>
-        <p:txBody>
-          <a:bodyPr vert="horz" lIns="91440" tIns="45720" rIns="91440" bIns="45720" rtlCol="0"/>
-          <a:lstStyle>
-            <a:lvl1pPr algn="r">
-              <a:defRPr sz="1200"/>
-            </a:lvl1pPr>
-          </a:lstStyle>
-          <a:p>
-            <a:fld id="{5282F153-3F37-0F45-9E97-73ACFA13230C}" type="datetimeFigureOut">
-              <a:rPr lang="en-US"/>
-              <a:t>7/23/19</a:t>
-            </a:fld>
-            <a:endParaRPr lang="en-US"/>
-          </a:p>
-        </p:txBody>
-      </p:sp>
-      <p:sp>
-        <p:nvSpPr>
-          <p:cNvPr id="4" name="Slide Image Placeholder 3"/>
-          <p:cNvSpPr>
-            <a:spLocks noGrp="1" noRot="1" noChangeAspect="1"/>
-          </p:cNvSpPr>
-          <p:nvPr>
-            <p:ph type="sldImg" idx="2"/>
-          </p:nvPr>
-        </p:nvSpPr>
-        <p:spPr>
-          <a:xfrm>
-            <a:off x="685800" y="1143000"/>
-            <a:ext cx="5486400" cy="3086100"/>
-          </a:xfrm>
-          <a:prstGeom prst="rect">
-            <a:avLst/>
-          </a:prstGeom>
-          <a:noFill/>
-          <a:ln w="12700">
-            <a:solidFill>
-              <a:prstClr val="black"/>
-            </a:solidFill>
-          </a:ln>
-        </p:spPr>
-        <p:txBody>
-          <a:bodyPr vert="horz" lIns="91440" tIns="45720" rIns="91440" bIns="45720" rtlCol="0" anchor="ctr"/>
-          <a:lstStyle/>
-          <a:p>
-            <a:endParaRPr lang="en-US"/>
-          </a:p>
-        </p:txBody>
-      </p:sp>
-      <p:sp>
-        <p:nvSpPr>
-          <p:cNvPr id="5" name="Notes Placeholder 4"/>
-          <p:cNvSpPr>
-            <a:spLocks noGrp="1"/>
-          </p:cNvSpPr>
-          <p:nvPr>
-            <p:ph type="body" sz="quarter" idx="3"/>
-          </p:nvPr>
-        </p:nvSpPr>
-        <p:spPr>
-          <a:xfrm>
-            <a:off x="685800" y="4400550"/>
-            <a:ext cx="5486400" cy="3600450"/>
-          </a:xfrm>
-          <a:prstGeom prst="rect">
-            <a:avLst/>
-          </a:prstGeom>
-        </p:spPr>
-        <p:txBody>
-          <a:bodyPr vert="horz" lIns="91440" tIns="45720" rIns="91440" bIns="45720" rtlCol="0"/>
-          <a:lstStyle/>
-          <a:p>
-            <a:pPr lvl="0"/>
-            <a:r>
-              <a:rPr lang="en-US"/>
-              <a:t>Click to edit Master text styles</a:t>
-            </a:r>
-          </a:p>
-          <a:p>
-            <a:pPr lvl="1"/>
-            <a:r>
-              <a:rPr lang="en-US"/>
-              <a:t>Second level</a:t>
-            </a:r>
-          </a:p>
-          <a:p>
-            <a:pPr lvl="2"/>
-            <a:r>
-              <a:rPr lang="en-US"/>
-              <a:t>Third level</a:t>
-            </a:r>
-          </a:p>
-          <a:p>
-            <a:pPr lvl="3"/>
-            <a:r>
-              <a:rPr lang="en-US"/>
-              <a:t>Fourth level</a:t>
-            </a:r>
-          </a:p>
-          <a:p>
-            <a:pPr lvl="4"/>
-            <a:r>
-              <a:rPr lang="en-US"/>
-              <a:t>Fifth level</a:t>
-            </a:r>
-          </a:p>
-        </p:txBody>
-      </p:sp>
-      <p:sp>
-        <p:nvSpPr>
-          <p:cNvPr id="6" name="Footer Placeholder 5"/>
-          <p:cNvSpPr>
-            <a:spLocks noGrp="1"/>
-          </p:cNvSpPr>
-          <p:nvPr>
-            <p:ph type="ftr" sz="quarter" idx="4"/>
-          </p:nvPr>
-        </p:nvSpPr>
-        <p:spPr>
-          <a:xfrm>
-            <a:off x="0" y="8685213"/>
-            <a:ext cx="2971800" cy="458787"/>
-          </a:xfrm>
-          <a:prstGeom prst="rect">
-            <a:avLst/>
-          </a:prstGeom>
-        </p:spPr>
-        <p:txBody>
-          <a:bodyPr vert="horz" lIns="91440" tIns="45720" rIns="91440" bIns="45720" rtlCol="0" anchor="b"/>
-          <a:lstStyle>
-            <a:lvl1pPr algn="l">
-              <a:defRPr sz="1200"/>
-            </a:lvl1pPr>
-          </a:lstStyle>
-          <a:p>
-            <a:endParaRPr lang="en-US"/>
-          </a:p>
-        </p:txBody>
-      </p:sp>
-      <p:sp>
-        <p:nvSpPr>
-          <p:cNvPr id="7" name="Slide Number Placeholder 6"/>
-          <p:cNvSpPr>
-            <a:spLocks noGrp="1"/>
-          </p:cNvSpPr>
-          <p:nvPr>
-            <p:ph type="sldNum" sz="quarter" idx="5"/>
-          </p:nvPr>
-        </p:nvSpPr>
-        <p:spPr>
-          <a:xfrm>
-            <a:off x="3884613" y="8685213"/>
-            <a:ext cx="2971800" cy="458787"/>
-          </a:xfrm>
-          <a:prstGeom prst="rect">
-            <a:avLst/>
-          </a:prstGeom>
-        </p:spPr>
-        <p:txBody>
-          <a:bodyPr vert="horz" lIns="91440" tIns="45720" rIns="91440" bIns="45720" rtlCol="0" anchor="b"/>
-          <a:lstStyle>
-            <a:lvl1pPr algn="r">
-              <a:defRPr sz="1200"/>
-            </a:lvl1pPr>
-          </a:lstStyle>
-          <a:p>
-            <a:fld id="{CE5E9CC1-C706-0F49-92D6-E571CC5EEA8F}" type="slidenum">
-              <a:rPr lang="en-US"/>
-              <a:t>‹#›</a:t>
-            </a:fld>
-            <a:endParaRPr lang="en-US"/>
-          </a:p>
-        </p:txBody>
-      </p:sp>
     </p:spTree>
     <p:extLst>
       <p:ext uri="{BB962C8B-B14F-4D97-AF65-F5344CB8AC3E}">
-        <p14:creationId xmlns:p14="http://schemas.microsoft.com/office/powerpoint/2010/main" val="1024086991"/>
+        <p14:creationId xmlns:p14="http://schemas.microsoft.com/office/powerpoint/2010/main" val="1821654246"/>
       </p:ext>
     </p:extLst>
   </p:cSld>
   <p:clrMap bg1="lt1" tx1="dk1" bg2="lt2" tx2="dk2" accent1="accent1" accent2="accent2" accent3="accent3" accent4="accent4" accent5="accent5" accent6="accent6" hlink="hlink" folHlink="folHlink"/>
   <p:notesStyle>
-    <a:lvl1pPr marL="0" algn="l" defTabSz="914400" rtl="0" eaLnBrk="1" latinLnBrk="0" hangingPunct="1">
+    <a:lvl1pPr marL="0" algn="l" defTabSz="914400" rtl="0" eaLnBrk="1" latinLnBrk="1" hangingPunct="1">
       <a:defRPr sz="1200" kern="1200">
         <a:solidFill>
           <a:schemeClr val="tx1"/>
@@ -379,7 +159,7 @@
         <a:cs typeface="+mn-cs"/>
       </a:defRPr>
     </a:lvl1pPr>
-    <a:lvl2pPr marL="457200" algn="l" defTabSz="914400" rtl="0" eaLnBrk="1" latinLnBrk="0" hangingPunct="1">
+    <a:lvl2pPr marL="457200" algn="l" defTabSz="914400" rtl="0" eaLnBrk="1" latinLnBrk="1" hangingPunct="1">
       <a:defRPr sz="1200" kern="1200">
         <a:solidFill>
           <a:schemeClr val="tx1"/>
@@ -389,7 +169,7 @@
         <a:cs typeface="+mn-cs"/>
       </a:defRPr>
     </a:lvl2pPr>
-    <a:lvl3pPr marL="914400" algn="l" defTabSz="914400" rtl="0" eaLnBrk="1" latinLnBrk="0" hangingPunct="1">
+    <a:lvl3pPr marL="914400" algn="l" defTabSz="914400" rtl="0" eaLnBrk="1" latinLnBrk="1" hangingPunct="1">
       <a:defRPr sz="1200" kern="1200">
         <a:solidFill>
           <a:schemeClr val="tx1"/>
@@ -399,7 +179,7 @@
         <a:cs typeface="+mn-cs"/>
       </a:defRPr>
     </a:lvl3pPr>
-    <a:lvl4pPr marL="1371600" algn="l" defTabSz="914400" rtl="0" eaLnBrk="1" latinLnBrk="0" hangingPunct="1">
+    <a:lvl4pPr marL="1371600" algn="l" defTabSz="914400" rtl="0" eaLnBrk="1" latinLnBrk="1" hangingPunct="1">
       <a:defRPr sz="1200" kern="1200">
         <a:solidFill>
           <a:schemeClr val="tx1"/>
@@ -409,7 +189,7 @@
         <a:cs typeface="+mn-cs"/>
       </a:defRPr>
     </a:lvl4pPr>
-    <a:lvl5pPr marL="1828800" algn="l" defTabSz="914400" rtl="0" eaLnBrk="1" latinLnBrk="0" hangingPunct="1">
+    <a:lvl5pPr marL="1828800" algn="l" defTabSz="914400" rtl="0" eaLnBrk="1" latinLnBrk="1" hangingPunct="1">
       <a:defRPr sz="1200" kern="1200">
         <a:solidFill>
           <a:schemeClr val="tx1"/>
@@ -419,7 +199,7 @@
         <a:cs typeface="+mn-cs"/>
       </a:defRPr>
     </a:lvl5pPr>
-    <a:lvl6pPr marL="2286000" algn="l" defTabSz="914400" rtl="0" eaLnBrk="1" latinLnBrk="0" hangingPunct="1">
+    <a:lvl6pPr marL="2286000" algn="l" defTabSz="914400" rtl="0" eaLnBrk="1" latinLnBrk="1" hangingPunct="1">
       <a:defRPr sz="1200" kern="1200">
         <a:solidFill>
           <a:schemeClr val="tx1"/>
@@ -429,7 +209,7 @@
         <a:cs typeface="+mn-cs"/>
       </a:defRPr>
     </a:lvl6pPr>
-    <a:lvl7pPr marL="2743200" algn="l" defTabSz="914400" rtl="0" eaLnBrk="1" latinLnBrk="0" hangingPunct="1">
+    <a:lvl7pPr marL="2743200" algn="l" defTabSz="914400" rtl="0" eaLnBrk="1" latinLnBrk="1" hangingPunct="1">
       <a:defRPr sz="1200" kern="1200">
         <a:solidFill>
           <a:schemeClr val="tx1"/>
@@ -439,7 +219,7 @@
         <a:cs typeface="+mn-cs"/>
       </a:defRPr>
     </a:lvl7pPr>
-    <a:lvl8pPr marL="3200400" algn="l" defTabSz="914400" rtl="0" eaLnBrk="1" latinLnBrk="0" hangingPunct="1">
+    <a:lvl8pPr marL="3200400" algn="l" defTabSz="914400" rtl="0" eaLnBrk="1" latinLnBrk="1" hangingPunct="1">
       <a:defRPr sz="1200" kern="1200">
         <a:solidFill>
           <a:schemeClr val="tx1"/>
@@ -449,7 +229,7 @@
         <a:cs typeface="+mn-cs"/>
       </a:defRPr>
     </a:lvl8pPr>
-    <a:lvl9pPr marL="3657600" algn="l" defTabSz="914400" rtl="0" eaLnBrk="1" latinLnBrk="0" hangingPunct="1">
+    <a:lvl9pPr marL="3657600" algn="l" defTabSz="914400" rtl="0" eaLnBrk="1" latinLnBrk="1" hangingPunct="1">
       <a:defRPr sz="1200" kern="1200">
         <a:solidFill>
           <a:schemeClr val="tx1"/>
@@ -507,10 +287,6 @@
           <a:bodyPr/>
           <a:lstStyle/>
           <a:p>
-            <a:r>
-              <a:rPr lang="en-US" dirty="0"/>
-              <a:t/>
-            </a:r>
             <a:endParaRPr lang="en-US" dirty="0"/>
           </a:p>
         </p:txBody>
@@ -595,10 +371,6 @@
           <a:bodyPr/>
           <a:lstStyle/>
           <a:p>
-            <a:r>
-              <a:rPr lang="en-US" dirty="0"/>
-              <a:t/>
-            </a:r>
             <a:endParaRPr lang="en-US" dirty="0"/>
           </a:p>
         </p:txBody>
@@ -683,10 +455,6 @@
           <a:bodyPr/>
           <a:lstStyle/>
           <a:p>
-            <a:r>
-              <a:rPr lang="en-US" dirty="0"/>
-              <a:t/>
-            </a:r>
             <a:endParaRPr lang="en-US" dirty="0"/>
           </a:p>
         </p:txBody>
@@ -771,10 +539,6 @@
           <a:bodyPr/>
           <a:lstStyle/>
           <a:p>
-            <a:r>
-              <a:rPr lang="en-US" dirty="0"/>
-              <a:t/>
-            </a:r>
             <a:endParaRPr lang="en-US" dirty="0"/>
           </a:p>
         </p:txBody>
@@ -859,10 +623,6 @@
           <a:bodyPr/>
           <a:lstStyle/>
           <a:p>
-            <a:r>
-              <a:rPr lang="en-US" dirty="0"/>
-              <a:t/>
-            </a:r>
             <a:endParaRPr lang="en-US" dirty="0"/>
           </a:p>
         </p:txBody>
@@ -947,10 +707,6 @@
           <a:bodyPr/>
           <a:lstStyle/>
           <a:p>
-            <a:r>
-              <a:rPr lang="en-US" dirty="0"/>
-              <a:t/>
-            </a:r>
             <a:endParaRPr lang="en-US" dirty="0"/>
           </a:p>
         </p:txBody>
@@ -1035,10 +791,6 @@
           <a:bodyPr/>
           <a:lstStyle/>
           <a:p>
-            <a:r>
-              <a:rPr lang="en-US" dirty="0"/>
-              <a:t/>
-            </a:r>
             <a:endParaRPr lang="en-US" dirty="0"/>
           </a:p>
         </p:txBody>
@@ -1061,94 +813,6 @@
             <a:fld id="{F7021451-1387-4CA6-816F-3879F97B5CBC}" type="slidenum">
               <a:rPr lang="en-US"/>
               <a:t>7</a:t>
-            </a:fld>
-            <a:endParaRPr lang="en-US"/>
-          </a:p>
-        </p:txBody>
-      </p:sp>
-    </p:spTree>
-    <p:extLst>
-      <p:ext uri="{BB962C8B-B14F-4D97-AF65-F5344CB8AC3E}">
-        <p14:creationId xmlns:p14="http://schemas.microsoft.com/office/powerpoint/2010/main" val="1024086991"/>
-      </p:ext>
-    </p:extLst>
-  </p:cSld>
-  <p:clrMapOvr>
-    <a:masterClrMapping/>
-  </p:clrMapOvr>
-</p:notes>
-</file>
-
-<file path=ppt/notesSlides/notesSlide8.xml><?xml version="1.0" encoding="utf-8"?>
-<p:notes xmlns:a="http://schemas.openxmlformats.org/drawingml/2006/main" xmlns:r="http://schemas.openxmlformats.org/officeDocument/2006/relationships" xmlns:p="http://schemas.openxmlformats.org/presentationml/2006/main">
-  <p:cSld>
-    <p:spTree>
-      <p:nvGrpSpPr>
-        <p:cNvPr id="1" name=""/>
-        <p:cNvGrpSpPr/>
-        <p:nvPr/>
-      </p:nvGrpSpPr>
-      <p:grpSpPr>
-        <a:xfrm>
-          <a:off x="0" y="0"/>
-          <a:ext cx="0" cy="0"/>
-          <a:chOff x="0" y="0"/>
-          <a:chExt cx="0" cy="0"/>
-        </a:xfrm>
-      </p:grpSpPr>
-      <p:sp>
-        <p:nvSpPr>
-          <p:cNvPr id="2" name="Slide Image Placeholder 1"/>
-          <p:cNvSpPr>
-            <a:spLocks noGrp="1" noRot="1" noChangeAspect="1"/>
-          </p:cNvSpPr>
-          <p:nvPr>
-            <p:ph type="sldImg"/>
-          </p:nvPr>
-        </p:nvSpPr>
-        <p:spPr/>
-      </p:sp>
-      <p:sp>
-        <p:nvSpPr>
-          <p:cNvPr id="3" name="Notes Placeholder 2"/>
-          <p:cNvSpPr>
-            <a:spLocks noGrp="1"/>
-          </p:cNvSpPr>
-          <p:nvPr>
-            <p:ph type="body" idx="1"/>
-          </p:nvPr>
-        </p:nvSpPr>
-        <p:spPr/>
-        <p:txBody>
-          <a:bodyPr/>
-          <a:lstStyle/>
-          <a:p>
-            <a:r>
-              <a:rPr lang="en-US" dirty="0"/>
-              <a:t/>
-            </a:r>
-            <a:endParaRPr lang="en-US" dirty="0"/>
-          </a:p>
-        </p:txBody>
-      </p:sp>
-      <p:sp>
-        <p:nvSpPr>
-          <p:cNvPr id="4" name="Slide Number Placeholder 3"/>
-          <p:cNvSpPr>
-            <a:spLocks noGrp="1"/>
-          </p:cNvSpPr>
-          <p:nvPr>
-            <p:ph type="sldNum" sz="quarter" idx="10"/>
-          </p:nvPr>
-        </p:nvSpPr>
-        <p:spPr/>
-        <p:txBody>
-          <a:bodyPr/>
-          <a:lstStyle/>
-          <a:p>
-            <a:fld id="{F7021451-1387-4CA6-816F-3879F97B5CBC}" type="slidenum">
-              <a:rPr lang="en-US"/>
-              <a:t>8</a:t>
             </a:fld>
             <a:endParaRPr lang="en-US"/>
           </a:p>
@@ -1200,6 +864,11 @@
 <file path=ppt/slideMasters/slideMaster1.xml><?xml version="1.0" encoding="utf-8"?>
 <p:sldMaster xmlns:a="http://schemas.openxmlformats.org/drawingml/2006/main" xmlns:r="http://schemas.openxmlformats.org/officeDocument/2006/relationships" xmlns:p="http://schemas.openxmlformats.org/presentationml/2006/main">
   <p:cSld>
+    <p:bg>
+      <p:bgRef idx="1001">
+        <a:schemeClr val="bg1"/>
+      </p:bgRef>
+    </p:bg>
     <p:spTree>
       <p:nvGrpSpPr>
         <p:cNvPr id="1" name=""/>
@@ -1482,6 +1151,7 @@
         <a:solidFill>
           <a:srgbClr val="F2F2F2"/>
         </a:solidFill>
+        <a:effectLst/>
       </p:bgPr>
     </p:bg>
     <p:spTree>
@@ -1519,7 +1189,7 @@
           <a:bodyPr wrap="square" rtlCol="0" anchor="ctr"/>
           <a:lstStyle/>
           <a:p>
-            <a:pPr algn="l" indent="0" marL="0">
+            <a:pPr marL="0" indent="0" algn="l">
               <a:buNone/>
             </a:pPr>
             <a:r>
@@ -1558,7 +1228,7 @@
           <a:bodyPr wrap="square" rtlCol="0" anchor="ctr"/>
           <a:lstStyle/>
           <a:p>
-            <a:pPr algn="l" indent="0" marL="0">
+            <a:pPr marL="0" indent="0" algn="l">
               <a:buNone/>
             </a:pPr>
             <a:r>
@@ -1597,7 +1267,7 @@
           <a:bodyPr wrap="square" rtlCol="0" anchor="ctr"/>
           <a:lstStyle/>
           <a:p>
-            <a:pPr algn="r" indent="0" marL="0">
+            <a:pPr marL="0" indent="0" algn="r">
               <a:buNone/>
             </a:pPr>
             <a:r>
@@ -1661,7 +1331,7 @@
           <a:bodyPr wrap="square" lIns="0" tIns="0" rIns="0" bIns="0" rtlCol="0" anchor="ctr"/>
           <a:lstStyle/>
           <a:p>
-            <a:pPr indent="0" marL="0">
+            <a:pPr marL="0" indent="0">
               <a:buNone/>
             </a:pPr>
             <a:r>
@@ -1806,7 +1476,7 @@
           <a:bodyPr wrap="square" rtlCol="0" anchor="ctr"/>
           <a:lstStyle/>
           <a:p>
-            <a:pPr algn="r" indent="0" marL="0">
+            <a:pPr marL="0" indent="0" algn="r">
               <a:buNone/>
             </a:pPr>
             <a:r>
@@ -1870,7 +1540,7 @@
           <a:bodyPr wrap="square" lIns="0" tIns="0" rIns="0" bIns="0" rtlCol="0" anchor="ctr"/>
           <a:lstStyle/>
           <a:p>
-            <a:pPr indent="0" marL="0">
+            <a:pPr marL="0" indent="0">
               <a:buNone/>
             </a:pPr>
             <a:r>
@@ -1972,15 +1642,69 @@
             <a:tbl>
               <a:tblPr/>
               <a:tblGrid>
-                <a:gridCol w="894080"/>
-                <a:gridCol w="894080"/>
-                <a:gridCol w="894080"/>
-                <a:gridCol w="894080"/>
-                <a:gridCol w="894080"/>
-                <a:gridCol w="894080"/>
-                <a:gridCol w="894080"/>
-                <a:gridCol w="894080"/>
-                <a:gridCol w="894080"/>
+                <a:gridCol w="894080">
+                  <a:extLst>
+                    <a:ext uri="{9D8B030D-6E8A-4147-A177-3AD203B41FA5}">
+                      <a16:colId xmlns:a16="http://schemas.microsoft.com/office/drawing/2014/main" val="20000"/>
+                    </a:ext>
+                  </a:extLst>
+                </a:gridCol>
+                <a:gridCol w="894080">
+                  <a:extLst>
+                    <a:ext uri="{9D8B030D-6E8A-4147-A177-3AD203B41FA5}">
+                      <a16:colId xmlns:a16="http://schemas.microsoft.com/office/drawing/2014/main" val="20001"/>
+                    </a:ext>
+                  </a:extLst>
+                </a:gridCol>
+                <a:gridCol w="894080">
+                  <a:extLst>
+                    <a:ext uri="{9D8B030D-6E8A-4147-A177-3AD203B41FA5}">
+                      <a16:colId xmlns:a16="http://schemas.microsoft.com/office/drawing/2014/main" val="20002"/>
+                    </a:ext>
+                  </a:extLst>
+                </a:gridCol>
+                <a:gridCol w="894080">
+                  <a:extLst>
+                    <a:ext uri="{9D8B030D-6E8A-4147-A177-3AD203B41FA5}">
+                      <a16:colId xmlns:a16="http://schemas.microsoft.com/office/drawing/2014/main" val="20003"/>
+                    </a:ext>
+                  </a:extLst>
+                </a:gridCol>
+                <a:gridCol w="894080">
+                  <a:extLst>
+                    <a:ext uri="{9D8B030D-6E8A-4147-A177-3AD203B41FA5}">
+                      <a16:colId xmlns:a16="http://schemas.microsoft.com/office/drawing/2014/main" val="20004"/>
+                    </a:ext>
+                  </a:extLst>
+                </a:gridCol>
+                <a:gridCol w="894080">
+                  <a:extLst>
+                    <a:ext uri="{9D8B030D-6E8A-4147-A177-3AD203B41FA5}">
+                      <a16:colId xmlns:a16="http://schemas.microsoft.com/office/drawing/2014/main" val="20005"/>
+                    </a:ext>
+                  </a:extLst>
+                </a:gridCol>
+                <a:gridCol w="894080">
+                  <a:extLst>
+                    <a:ext uri="{9D8B030D-6E8A-4147-A177-3AD203B41FA5}">
+                      <a16:colId xmlns:a16="http://schemas.microsoft.com/office/drawing/2014/main" val="20006"/>
+                    </a:ext>
+                  </a:extLst>
+                </a:gridCol>
+                <a:gridCol w="894080">
+                  <a:extLst>
+                    <a:ext uri="{9D8B030D-6E8A-4147-A177-3AD203B41FA5}">
+                      <a16:colId xmlns:a16="http://schemas.microsoft.com/office/drawing/2014/main" val="20007"/>
+                    </a:ext>
+                  </a:extLst>
+                </a:gridCol>
+                <a:gridCol w="894080">
+                  <a:extLst>
+                    <a:ext uri="{9D8B030D-6E8A-4147-A177-3AD203B41FA5}">
+                      <a16:colId xmlns:a16="http://schemas.microsoft.com/office/drawing/2014/main" val="20008"/>
+                    </a:ext>
+                  </a:extLst>
+                </a:gridCol>
               </a:tblGrid>
               <a:tr h="457200">
                 <a:tc>
@@ -1988,7 +1712,7 @@
                     <a:bodyPr/>
                     <a:lstStyle/>
                     <a:p>
-                      <a:pPr algn="ctr" indent="0" marL="0">
+                      <a:pPr marL="0" indent="0" algn="ctr">
                         <a:buNone/>
                       </a:pPr>
                       <a:r>
@@ -2009,7 +1733,7 @@
                       </a:endParaRPr>
                     </a:p>
                   </a:txBody>
-                  <a:tcPr marL="91440" marR="91440" marT="45720" marB="45720">
+                  <a:tcPr>
                     <a:lnL w="6350" cap="flat" cmpd="sng" algn="ctr">
                       <a:solidFill>
                         <a:srgbClr val="CCCCCC"/>
@@ -2056,7 +1780,7 @@
                     <a:bodyPr/>
                     <a:lstStyle/>
                     <a:p>
-                      <a:pPr algn="ctr" indent="0" marL="0">
+                      <a:pPr marL="0" indent="0" algn="ctr">
                         <a:buNone/>
                       </a:pPr>
                       <a:r>
@@ -2077,7 +1801,7 @@
                       </a:endParaRPr>
                     </a:p>
                   </a:txBody>
-                  <a:tcPr marL="91440" marR="91440" marT="45720" marB="45720">
+                  <a:tcPr>
                     <a:lnL w="6350" cap="flat" cmpd="sng" algn="ctr">
                       <a:solidFill>
                         <a:srgbClr val="CCCCCC"/>
@@ -2124,7 +1848,7 @@
                     <a:bodyPr/>
                     <a:lstStyle/>
                     <a:p>
-                      <a:pPr algn="ctr" indent="0" marL="0">
+                      <a:pPr marL="0" indent="0" algn="ctr">
                         <a:buNone/>
                       </a:pPr>
                       <a:r>
@@ -2145,7 +1869,7 @@
                       </a:endParaRPr>
                     </a:p>
                   </a:txBody>
-                  <a:tcPr marL="91440" marR="91440" marT="45720" marB="45720">
+                  <a:tcPr>
                     <a:lnL w="6350" cap="flat" cmpd="sng" algn="ctr">
                       <a:solidFill>
                         <a:srgbClr val="CCCCCC"/>
@@ -2192,7 +1916,7 @@
                     <a:bodyPr/>
                     <a:lstStyle/>
                     <a:p>
-                      <a:pPr algn="ctr" indent="0" marL="0">
+                      <a:pPr marL="0" indent="0" algn="ctr">
                         <a:buNone/>
                       </a:pPr>
                       <a:r>
@@ -2213,7 +1937,7 @@
                       </a:endParaRPr>
                     </a:p>
                   </a:txBody>
-                  <a:tcPr marL="91440" marR="91440" marT="45720" marB="45720">
+                  <a:tcPr>
                     <a:lnL w="6350" cap="flat" cmpd="sng" algn="ctr">
                       <a:solidFill>
                         <a:srgbClr val="CCCCCC"/>
@@ -2260,7 +1984,7 @@
                     <a:bodyPr/>
                     <a:lstStyle/>
                     <a:p>
-                      <a:pPr algn="ctr" indent="0" marL="0">
+                      <a:pPr marL="0" indent="0" algn="ctr">
                         <a:buNone/>
                       </a:pPr>
                       <a:r>
@@ -2281,7 +2005,7 @@
                       </a:endParaRPr>
                     </a:p>
                   </a:txBody>
-                  <a:tcPr marL="91440" marR="91440" marT="45720" marB="45720">
+                  <a:tcPr>
                     <a:lnL w="6350" cap="flat" cmpd="sng" algn="ctr">
                       <a:solidFill>
                         <a:srgbClr val="CCCCCC"/>
@@ -2328,7 +2052,7 @@
                     <a:bodyPr/>
                     <a:lstStyle/>
                     <a:p>
-                      <a:pPr algn="ctr" indent="0" marL="0">
+                      <a:pPr marL="0" indent="0" algn="ctr">
                         <a:buNone/>
                       </a:pPr>
                       <a:r>
@@ -2349,7 +2073,7 @@
                       </a:endParaRPr>
                     </a:p>
                   </a:txBody>
-                  <a:tcPr marL="91440" marR="91440" marT="45720" marB="45720">
+                  <a:tcPr>
                     <a:lnL w="6350" cap="flat" cmpd="sng" algn="ctr">
                       <a:solidFill>
                         <a:srgbClr val="CCCCCC"/>
@@ -2396,7 +2120,7 @@
                     <a:bodyPr/>
                     <a:lstStyle/>
                     <a:p>
-                      <a:pPr algn="ctr" indent="0" marL="0">
+                      <a:pPr marL="0" indent="0" algn="ctr">
                         <a:buNone/>
                       </a:pPr>
                       <a:r>
@@ -2417,7 +2141,7 @@
                       </a:endParaRPr>
                     </a:p>
                   </a:txBody>
-                  <a:tcPr marL="91440" marR="91440" marT="45720" marB="45720">
+                  <a:tcPr>
                     <a:lnL w="6350" cap="flat" cmpd="sng" algn="ctr">
                       <a:solidFill>
                         <a:srgbClr val="CCCCCC"/>
@@ -2464,7 +2188,7 @@
                     <a:bodyPr/>
                     <a:lstStyle/>
                     <a:p>
-                      <a:pPr algn="ctr" indent="0" marL="0">
+                      <a:pPr marL="0" indent="0" algn="ctr">
                         <a:buNone/>
                       </a:pPr>
                       <a:r>
@@ -2485,7 +2209,7 @@
                       </a:endParaRPr>
                     </a:p>
                   </a:txBody>
-                  <a:tcPr marL="91440" marR="91440" marT="45720" marB="45720">
+                  <a:tcPr>
                     <a:lnL w="6350" cap="flat" cmpd="sng" algn="ctr">
                       <a:solidFill>
                         <a:srgbClr val="CCCCCC"/>
@@ -2532,7 +2256,7 @@
                     <a:bodyPr/>
                     <a:lstStyle/>
                     <a:p>
-                      <a:pPr algn="ctr" indent="0" marL="0">
+                      <a:pPr marL="0" indent="0" algn="ctr">
                         <a:buNone/>
                       </a:pPr>
                       <a:r>
@@ -2553,7 +2277,7 @@
                       </a:endParaRPr>
                     </a:p>
                   </a:txBody>
-                  <a:tcPr marL="91440" marR="91440" marT="45720" marB="45720">
+                  <a:tcPr>
                     <a:lnL w="6350" cap="flat" cmpd="sng" algn="ctr">
                       <a:solidFill>
                         <a:srgbClr val="CCCCCC"/>
@@ -2595,6 +2319,11 @@
                     </a:solidFill>
                   </a:tcPr>
                 </a:tc>
+                <a:extLst>
+                  <a:ext uri="{0D108BD9-81ED-4DB2-BD59-A6C34878D82A}">
+                    <a16:rowId xmlns:a16="http://schemas.microsoft.com/office/drawing/2014/main" val="10000"/>
+                  </a:ext>
+                </a:extLst>
               </a:tr>
               <a:tr h="457200">
                 <a:tc>
@@ -2602,7 +2331,7 @@
                     <a:bodyPr/>
                     <a:lstStyle/>
                     <a:p>
-                      <a:pPr algn="ctr" indent="0" marL="0">
+                      <a:pPr marL="0" indent="0" algn="ctr">
                         <a:buNone/>
                       </a:pPr>
                       <a:r>
@@ -2623,7 +2352,7 @@
                       </a:endParaRPr>
                     </a:p>
                   </a:txBody>
-                  <a:tcPr marL="91440" marR="91440" marT="45720" marB="45720">
+                  <a:tcPr>
                     <a:lnL w="6350" cap="flat" cmpd="sng" algn="ctr">
                       <a:solidFill>
                         <a:srgbClr val="CCCCCC"/>
@@ -2667,7 +2396,7 @@
                     <a:bodyPr/>
                     <a:lstStyle/>
                     <a:p>
-                      <a:pPr algn="ctr" indent="0" marL="0">
+                      <a:pPr marL="0" indent="0" algn="ctr">
                         <a:buNone/>
                       </a:pPr>
                       <a:r>
@@ -2688,7 +2417,7 @@
                       </a:endParaRPr>
                     </a:p>
                   </a:txBody>
-                  <a:tcPr marL="91440" marR="91440" marT="45720" marB="45720">
+                  <a:tcPr>
                     <a:lnL w="6350" cap="flat" cmpd="sng" algn="ctr">
                       <a:solidFill>
                         <a:srgbClr val="CCCCCC"/>
@@ -2732,7 +2461,7 @@
                     <a:bodyPr/>
                     <a:lstStyle/>
                     <a:p>
-                      <a:pPr algn="ctr" indent="0" marL="0">
+                      <a:pPr marL="0" indent="0" algn="ctr">
                         <a:buNone/>
                       </a:pPr>
                       <a:r>
@@ -2753,7 +2482,7 @@
                       </a:endParaRPr>
                     </a:p>
                   </a:txBody>
-                  <a:tcPr marL="91440" marR="91440" marT="45720" marB="45720">
+                  <a:tcPr>
                     <a:lnL w="6350" cap="flat" cmpd="sng" algn="ctr">
                       <a:solidFill>
                         <a:srgbClr val="CCCCCC"/>
@@ -2797,7 +2526,7 @@
                     <a:bodyPr/>
                     <a:lstStyle/>
                     <a:p>
-                      <a:pPr algn="ctr" indent="0" marL="0">
+                      <a:pPr marL="0" indent="0" algn="ctr">
                         <a:buNone/>
                       </a:pPr>
                       <a:r>
@@ -2818,7 +2547,7 @@
                       </a:endParaRPr>
                     </a:p>
                   </a:txBody>
-                  <a:tcPr marL="91440" marR="91440" marT="45720" marB="45720">
+                  <a:tcPr>
                     <a:lnL w="6350" cap="flat" cmpd="sng" algn="ctr">
                       <a:solidFill>
                         <a:srgbClr val="CCCCCC"/>
@@ -2862,7 +2591,7 @@
                     <a:bodyPr/>
                     <a:lstStyle/>
                     <a:p>
-                      <a:pPr algn="ctr" indent="0" marL="0">
+                      <a:pPr marL="0" indent="0" algn="ctr">
                         <a:buNone/>
                       </a:pPr>
                       <a:r>
@@ -2883,7 +2612,7 @@
                       </a:endParaRPr>
                     </a:p>
                   </a:txBody>
-                  <a:tcPr marL="91440" marR="91440" marT="45720" marB="45720">
+                  <a:tcPr>
                     <a:lnL w="6350" cap="flat" cmpd="sng" algn="ctr">
                       <a:solidFill>
                         <a:srgbClr val="CCCCCC"/>
@@ -2927,7 +2656,7 @@
                     <a:bodyPr/>
                     <a:lstStyle/>
                     <a:p>
-                      <a:pPr algn="ctr" indent="0" marL="0">
+                      <a:pPr marL="0" indent="0" algn="ctr">
                         <a:buNone/>
                       </a:pPr>
                       <a:r>
@@ -2948,7 +2677,7 @@
                       </a:endParaRPr>
                     </a:p>
                   </a:txBody>
-                  <a:tcPr marL="91440" marR="91440" marT="45720" marB="45720">
+                  <a:tcPr>
                     <a:lnL w="6350" cap="flat" cmpd="sng" algn="ctr">
                       <a:solidFill>
                         <a:srgbClr val="CCCCCC"/>
@@ -2992,7 +2721,7 @@
                     <a:bodyPr/>
                     <a:lstStyle/>
                     <a:p>
-                      <a:pPr algn="ctr" indent="0" marL="0">
+                      <a:pPr marL="0" indent="0" algn="ctr">
                         <a:buNone/>
                       </a:pPr>
                       <a:r>
@@ -3013,7 +2742,7 @@
                       </a:endParaRPr>
                     </a:p>
                   </a:txBody>
-                  <a:tcPr marL="91440" marR="91440" marT="45720" marB="45720">
+                  <a:tcPr>
                     <a:lnL w="6350" cap="flat" cmpd="sng" algn="ctr">
                       <a:solidFill>
                         <a:srgbClr val="CCCCCC"/>
@@ -3057,7 +2786,7 @@
                     <a:bodyPr/>
                     <a:lstStyle/>
                     <a:p>
-                      <a:pPr algn="ctr" indent="0" marL="0">
+                      <a:pPr marL="0" indent="0" algn="ctr">
                         <a:buNone/>
                       </a:pPr>
                       <a:r>
@@ -3078,7 +2807,7 @@
                       </a:endParaRPr>
                     </a:p>
                   </a:txBody>
-                  <a:tcPr marL="91440" marR="91440" marT="45720" marB="45720">
+                  <a:tcPr>
                     <a:lnL w="6350" cap="flat" cmpd="sng" algn="ctr">
                       <a:solidFill>
                         <a:srgbClr val="CCCCCC"/>
@@ -3122,7 +2851,7 @@
                     <a:bodyPr/>
                     <a:lstStyle/>
                     <a:p>
-                      <a:pPr algn="ctr" indent="0" marL="0">
+                      <a:pPr marL="0" indent="0" algn="ctr">
                         <a:buNone/>
                       </a:pPr>
                       <a:r>
@@ -3143,7 +2872,7 @@
                       </a:endParaRPr>
                     </a:p>
                   </a:txBody>
-                  <a:tcPr marL="91440" marR="91440" marT="45720" marB="45720">
+                  <a:tcPr>
                     <a:lnL w="6350" cap="flat" cmpd="sng" algn="ctr">
                       <a:solidFill>
                         <a:srgbClr val="CCCCCC"/>
@@ -3182,6 +2911,11 @@
                     </a:lnB>
                   </a:tcPr>
                 </a:tc>
+                <a:extLst>
+                  <a:ext uri="{0D108BD9-81ED-4DB2-BD59-A6C34878D82A}">
+                    <a16:rowId xmlns:a16="http://schemas.microsoft.com/office/drawing/2014/main" val="10001"/>
+                  </a:ext>
+                </a:extLst>
               </a:tr>
             </a:tbl>
           </a:graphicData>
@@ -3208,7 +2942,7 @@
           <a:bodyPr wrap="square" rtlCol="0" anchor="ctr"/>
           <a:lstStyle/>
           <a:p>
-            <a:pPr algn="r" indent="0" marL="0">
+            <a:pPr marL="0" indent="0" algn="r">
               <a:buNone/>
             </a:pPr>
             <a:r>
@@ -3272,7 +3006,7 @@
           <a:bodyPr wrap="square" lIns="0" tIns="0" rIns="0" bIns="0" rtlCol="0" anchor="ctr"/>
           <a:lstStyle/>
           <a:p>
-            <a:pPr indent="0" marL="0">
+            <a:pPr marL="0" indent="0">
               <a:buNone/>
             </a:pPr>
             <a:r>
@@ -3417,7 +3151,7 @@
           <a:bodyPr wrap="square" rtlCol="0" anchor="ctr"/>
           <a:lstStyle/>
           <a:p>
-            <a:pPr algn="r" indent="0" marL="0">
+            <a:pPr marL="0" indent="0" algn="r">
               <a:buNone/>
             </a:pPr>
             <a:r>
@@ -3481,7 +3215,7 @@
           <a:bodyPr wrap="square" lIns="0" tIns="0" rIns="0" bIns="0" rtlCol="0" anchor="ctr"/>
           <a:lstStyle/>
           <a:p>
-            <a:pPr indent="0" marL="0">
+            <a:pPr marL="0" indent="0">
               <a:buNone/>
             </a:pPr>
             <a:r>
@@ -3626,7 +3360,7 @@
           <a:bodyPr wrap="square" rtlCol="0" anchor="ctr"/>
           <a:lstStyle/>
           <a:p>
-            <a:pPr algn="r" indent="0" marL="0">
+            <a:pPr marL="0" indent="0" algn="r">
               <a:buNone/>
             </a:pPr>
             <a:r>
@@ -3690,7 +3424,7 @@
           <a:bodyPr wrap="square" lIns="0" tIns="0" rIns="0" bIns="0" rtlCol="0" anchor="ctr"/>
           <a:lstStyle/>
           <a:p>
-            <a:pPr indent="0" marL="0">
+            <a:pPr marL="0" indent="0">
               <a:buNone/>
             </a:pPr>
             <a:r>
@@ -3816,20 +3550,20 @@
       </p:sp>
       <p:pic>
         <p:nvPicPr>
-          <p:cNvPr id="4" name="Image 0" descr="/home/user/SoC_Design_and_Programming/diagrams/section3/zoom/master_fault_flow.png">    </p:cNvPr>
+          <p:cNvPr id="4" name="Image 0" descr="/home/user/SoC_Design_and_Programming/diagrams/section3/zoom/master_fault_flow.png"/>
           <p:cNvPicPr>
             <a:picLocks noChangeAspect="1"/>
           </p:cNvPicPr>
           <p:nvPr/>
         </p:nvPicPr>
         <p:blipFill>
-          <a:blip r:embed="rId1"/>
-          <a:srcRect l="0" r="0" t="0" b="0"/>
+          <a:blip r:embed="rId3"/>
+          <a:srcRect/>
           <a:stretch/>
         </p:blipFill>
         <p:spPr>
           <a:xfrm>
-            <a:off x="548640" y="2404499"/>
+            <a:off x="548640" y="2722178"/>
             <a:ext cx="8046720" cy="1683242"/>
           </a:xfrm>
           <a:prstGeom prst="rect">
@@ -3858,7 +3592,7 @@
           <a:bodyPr wrap="square" rtlCol="0" anchor="ctr"/>
           <a:lstStyle/>
           <a:p>
-            <a:pPr algn="r" indent="0" marL="0">
+            <a:pPr marL="0" indent="0" algn="r">
               <a:buNone/>
             </a:pPr>
             <a:r>
@@ -3922,7 +3656,7 @@
           <a:bodyPr wrap="square" lIns="0" tIns="0" rIns="0" bIns="0" rtlCol="0" anchor="ctr"/>
           <a:lstStyle/>
           <a:p>
-            <a:pPr indent="0" marL="0">
+            <a:pPr marL="0" indent="0">
               <a:buNone/>
             </a:pPr>
             <a:r>
@@ -4046,7 +3780,7 @@
           <a:bodyPr wrap="square" rtlCol="0" anchor="ctr"/>
           <a:lstStyle/>
           <a:p>
-            <a:pPr algn="r" indent="0" marL="0">
+            <a:pPr marL="0" indent="0" algn="r">
               <a:buNone/>
             </a:pPr>
             <a:r>
@@ -4059,238 +3793,6 @@
                 <a:cs typeface="Noto Sans CJK KR" pitchFamily="34" charset="-120"/>
               </a:rPr>
               <a:t>7</a:t>
-            </a:r>
-            <a:endParaRPr lang="en-US" sz="1200" dirty="0"/>
-          </a:p>
-        </p:txBody>
-      </p:sp>
-    </p:spTree>
-  </p:cSld>
-  <p:clrMapOvr>
-    <a:masterClrMapping/>
-  </p:clrMapOvr>
-</p:sld>
-</file>
-
-<file path=ppt/slides/slide8.xml><?xml version="1.0" encoding="utf-8"?>
-<p:sld xmlns:a="http://schemas.openxmlformats.org/drawingml/2006/main" xmlns:r="http://schemas.openxmlformats.org/officeDocument/2006/relationships" xmlns:p="http://schemas.openxmlformats.org/presentationml/2006/main">
-  <p:cSld name="Slide 8">
-    <p:spTree>
-      <p:nvGrpSpPr>
-        <p:cNvPr id="1" name=""/>
-        <p:cNvGrpSpPr/>
-        <p:nvPr/>
-      </p:nvGrpSpPr>
-      <p:grpSpPr>
-        <a:xfrm>
-          <a:off x="0" y="0"/>
-          <a:ext cx="0" cy="0"/>
-          <a:chOff x="0" y="0"/>
-          <a:chExt cx="0" cy="0"/>
-        </a:xfrm>
-      </p:grpSpPr>
-      <p:sp>
-        <p:nvSpPr>
-          <p:cNvPr id="2" name="Text 0"/>
-          <p:cNvSpPr/>
-          <p:nvPr/>
-        </p:nvSpPr>
-        <p:spPr>
-          <a:xfrm>
-            <a:off x="548640" y="274320"/>
-            <a:ext cx="8046720" cy="777240"/>
-          </a:xfrm>
-          <a:prstGeom prst="rect">
-            <a:avLst/>
-          </a:prstGeom>
-          <a:noFill/>
-          <a:ln/>
-        </p:spPr>
-        <p:txBody>
-          <a:bodyPr wrap="square" lIns="0" tIns="0" rIns="0" bIns="0" rtlCol="0" anchor="ctr"/>
-          <a:lstStyle/>
-          <a:p>
-            <a:pPr indent="0" marL="0">
-              <a:buNone/>
-            </a:pPr>
-            <a:r>
-              <a:rPr lang="en-US" sz="3600" b="1" dirty="0">
-                <a:solidFill>
-                  <a:srgbClr val="111111"/>
-                </a:solidFill>
-                <a:latin typeface="Noto Sans CJK KR" pitchFamily="34" charset="0"/>
-                <a:ea typeface="Noto Sans CJK KR" pitchFamily="34" charset="-122"/>
-                <a:cs typeface="Noto Sans CJK KR" pitchFamily="34" charset="-120"/>
-              </a:rPr>
-              <a:t>Slave halt 흐름도</a:t>
-            </a:r>
-            <a:endParaRPr lang="en-US" sz="3600" dirty="0"/>
-          </a:p>
-        </p:txBody>
-      </p:sp>
-      <p:sp>
-        <p:nvSpPr>
-          <p:cNvPr id="3" name="Text 1"/>
-          <p:cNvSpPr/>
-          <p:nvPr/>
-        </p:nvSpPr>
-        <p:spPr>
-          <a:xfrm>
-            <a:off x="548640" y="1188720"/>
-            <a:ext cx="8046720" cy="685800"/>
-          </a:xfrm>
-          <a:prstGeom prst="rect">
-            <a:avLst/>
-          </a:prstGeom>
-          <a:noFill/>
-          <a:ln/>
-        </p:spPr>
-        <p:txBody>
-          <a:bodyPr wrap="square" rtlCol="0" anchor="t"/>
-          <a:lstStyle/>
-          <a:p>
-            <a:pPr marL="342900" indent="-342900">
-              <a:spcAft>
-                <a:spcPts val="600"/>
-              </a:spcAft>
-              <a:buSzPct val="100000"/>
-              <a:buChar char="•"/>
-            </a:pPr>
-            <a:r>
-              <a:rPr lang="en-US" sz="1600" dirty="0">
-                <a:solidFill>
-                  <a:srgbClr val="222222"/>
-                </a:solidFill>
-                <a:latin typeface="Noto Sans CJK KR" pitchFamily="34" charset="0"/>
-                <a:ea typeface="Noto Sans CJK KR" pitchFamily="34" charset="-122"/>
-                <a:cs typeface="Noto Sans CJK KR" pitchFamily="34" charset="-120"/>
-              </a:rPr>
-              <a:t>Master broadcast에서 halt_mask 추출</a:t>
-            </a:r>
-            <a:endParaRPr lang="en-US" sz="1600" dirty="0"/>
-          </a:p>
-          <a:p>
-            <a:pPr marL="342900" indent="-342900">
-              <a:spcAft>
-                <a:spcPts val="600"/>
-              </a:spcAft>
-              <a:buSzPct val="100000"/>
-              <a:buChar char="•"/>
-            </a:pPr>
-            <a:r>
-              <a:rPr lang="en-US" sz="1600" dirty="0">
-                <a:solidFill>
-                  <a:srgbClr val="222222"/>
-                </a:solidFill>
-                <a:latin typeface="Noto Sans CJK KR" pitchFamily="34" charset="0"/>
-                <a:ea typeface="Noto Sans CJK KR" pitchFamily="34" charset="-122"/>
-                <a:cs typeface="Noto Sans CJK KR" pitchFamily="34" charset="-120"/>
-              </a:rPr>
-              <a:t>슬롯 시퀀서가 active_slot에서 halt된 슬롯을 제외</a:t>
-            </a:r>
-            <a:endParaRPr lang="en-US" sz="1600" dirty="0"/>
-          </a:p>
-          <a:p>
-            <a:pPr marL="342900" indent="-342900">
-              <a:spcAft>
-                <a:spcPts val="600"/>
-              </a:spcAft>
-              <a:buSzPct val="100000"/>
-              <a:buChar char="•"/>
-            </a:pPr>
-            <a:r>
-              <a:rPr lang="en-US" sz="1600" dirty="0">
-                <a:solidFill>
-                  <a:srgbClr val="222222"/>
-                </a:solidFill>
-                <a:latin typeface="Noto Sans CJK KR" pitchFamily="34" charset="0"/>
-                <a:ea typeface="Noto Sans CJK KR" pitchFamily="34" charset="-122"/>
-                <a:cs typeface="Noto Sans CJK KR" pitchFamily="34" charset="-120"/>
-              </a:rPr>
-              <a:t>해당 슬롯은 TX를 발행하지 않음</a:t>
-            </a:r>
-            <a:endParaRPr lang="en-US" sz="1600" dirty="0"/>
-          </a:p>
-          <a:p>
-            <a:pPr marL="342900" indent="-342900">
-              <a:spcAft>
-                <a:spcPts val="600"/>
-              </a:spcAft>
-              <a:buSzPct val="100000"/>
-              <a:buChar char="•"/>
-            </a:pPr>
-            <a:r>
-              <a:rPr lang="en-US" sz="1600" dirty="0">
-                <a:solidFill>
-                  <a:srgbClr val="222222"/>
-                </a:solidFill>
-                <a:latin typeface="Noto Sans CJK KR" pitchFamily="34" charset="0"/>
-                <a:ea typeface="Noto Sans CJK KR" pitchFamily="34" charset="-122"/>
-                <a:cs typeface="Noto Sans CJK KR" pitchFamily="34" charset="-120"/>
-              </a:rPr>
-              <a:t>Master가 비트를 다시 0으로 보내면 자동 재개</a:t>
-            </a:r>
-            <a:endParaRPr lang="en-US" sz="1600" dirty="0"/>
-          </a:p>
-        </p:txBody>
-      </p:sp>
-      <p:pic>
-        <p:nvPicPr>
-          <p:cNvPr id="4" name="Image 0" descr="/home/user/SoC_Design_and_Programming/diagrams/section3/zoom/slave_halt_flow.png">    </p:cNvPr>
-          <p:cNvPicPr>
-            <a:picLocks noChangeAspect="1"/>
-          </p:cNvPicPr>
-          <p:nvPr/>
-        </p:nvPicPr>
-        <p:blipFill>
-          <a:blip r:embed="rId1"/>
-          <a:srcRect l="0" r="0" t="0" b="0"/>
-          <a:stretch/>
-        </p:blipFill>
-        <p:spPr>
-          <a:xfrm>
-            <a:off x="548640" y="2291598"/>
-            <a:ext cx="8046720" cy="1909043"/>
-          </a:xfrm>
-          <a:prstGeom prst="rect">
-            <a:avLst/>
-          </a:prstGeom>
-        </p:spPr>
-      </p:pic>
-      <p:sp>
-        <p:nvSpPr>
-          <p:cNvPr id="5" name="Text 2"/>
-          <p:cNvSpPr/>
-          <p:nvPr/>
-        </p:nvSpPr>
-        <p:spPr>
-          <a:xfrm>
-            <a:off x="8503920" y="4754880"/>
-            <a:ext cx="457200" cy="274320"/>
-          </a:xfrm>
-          <a:prstGeom prst="rect">
-            <a:avLst/>
-          </a:prstGeom>
-          <a:noFill/>
-          <a:ln/>
-        </p:spPr>
-        <p:txBody>
-          <a:bodyPr wrap="square" rtlCol="0" anchor="ctr"/>
-          <a:lstStyle/>
-          <a:p>
-            <a:pPr algn="r" indent="0" marL="0">
-              <a:buNone/>
-            </a:pPr>
-            <a:r>
-              <a:rPr lang="en-US" sz="1200" dirty="0">
-                <a:solidFill>
-                  <a:srgbClr val="999999"/>
-                </a:solidFill>
-                <a:latin typeface="Noto Sans CJK KR" pitchFamily="34" charset="0"/>
-                <a:ea typeface="Noto Sans CJK KR" pitchFamily="34" charset="-122"/>
-                <a:cs typeface="Noto Sans CJK KR" pitchFamily="34" charset="-120"/>
-              </a:rPr>
-              <a:t>8</a:t>
             </a:r>
             <a:endParaRPr lang="en-US" sz="1200" dirty="0"/>
           </a:p>
@@ -4597,4 +4099,319 @@
     </a:ext>
   </a:extLst>
 </a:theme>
+</file>
+
+<file path=ppt/theme/theme2.xml><?xml version="1.0" encoding="utf-8"?>
+<a:theme xmlns:a="http://schemas.openxmlformats.org/drawingml/2006/main" name="Office 테마">
+  <a:themeElements>
+    <a:clrScheme name="Office">
+      <a:dk1>
+        <a:sysClr val="windowText" lastClr="000000"/>
+      </a:dk1>
+      <a:lt1>
+        <a:sysClr val="window" lastClr="FFFFFF"/>
+      </a:lt1>
+      <a:dk2>
+        <a:srgbClr val="0E2841"/>
+      </a:dk2>
+      <a:lt2>
+        <a:srgbClr val="E8E8E8"/>
+      </a:lt2>
+      <a:accent1>
+        <a:srgbClr val="156082"/>
+      </a:accent1>
+      <a:accent2>
+        <a:srgbClr val="E97132"/>
+      </a:accent2>
+      <a:accent3>
+        <a:srgbClr val="196B24"/>
+      </a:accent3>
+      <a:accent4>
+        <a:srgbClr val="0F9ED5"/>
+      </a:accent4>
+      <a:accent5>
+        <a:srgbClr val="A02B93"/>
+      </a:accent5>
+      <a:accent6>
+        <a:srgbClr val="4EA72E"/>
+      </a:accent6>
+      <a:hlink>
+        <a:srgbClr val="467886"/>
+      </a:hlink>
+      <a:folHlink>
+        <a:srgbClr val="96607D"/>
+      </a:folHlink>
+    </a:clrScheme>
+    <a:fontScheme name="Office">
+      <a:majorFont>
+        <a:latin typeface="맑은 고딕" panose="02110004020202020204"/>
+        <a:ea typeface=""/>
+        <a:cs typeface=""/>
+        <a:font script="Jpan" typeface="游ゴシック Light"/>
+        <a:font script="Hang" typeface="맑은 고딕"/>
+        <a:font script="Hans" typeface="等线 Light"/>
+        <a:font script="Hant" typeface="新細明體"/>
+        <a:font script="Arab" typeface="Times New Roman"/>
+        <a:font script="Hebr" typeface="Times New Roman"/>
+        <a:font script="Thai" typeface="Angsana New"/>
+        <a:font script="Ethi" typeface="Nyala"/>
+        <a:font script="Beng" typeface="Vrinda"/>
+        <a:font script="Gujr" typeface="Shruti"/>
+        <a:font script="Khmr" typeface="MoolBoran"/>
+        <a:font script="Knda" typeface="Tunga"/>
+        <a:font script="Guru" typeface="Raavi"/>
+        <a:font script="Cans" typeface="Euphemia"/>
+        <a:font script="Cher" typeface="Plantagenet Cherokee"/>
+        <a:font script="Yiii" typeface="Microsoft Yi Baiti"/>
+        <a:font script="Tibt" typeface="Microsoft Himalaya"/>
+        <a:font script="Thaa" typeface="MV Boli"/>
+        <a:font script="Deva" typeface="Mangal"/>
+        <a:font script="Telu" typeface="Gautami"/>
+        <a:font script="Taml" typeface="Latha"/>
+        <a:font script="Syrc" typeface="Estrangelo Edessa"/>
+        <a:font script="Orya" typeface="Kalinga"/>
+        <a:font script="Mlym" typeface="Kartika"/>
+        <a:font script="Laoo" typeface="DokChampa"/>
+        <a:font script="Sinh" typeface="Iskoola Pota"/>
+        <a:font script="Mong" typeface="Mongolian Baiti"/>
+        <a:font script="Viet" typeface="Times New Roman"/>
+        <a:font script="Uigh" typeface="Microsoft Uighur"/>
+        <a:font script="Geor" typeface="Sylfaen"/>
+        <a:font script="Armn" typeface="Arial"/>
+        <a:font script="Bugi" typeface="Leelawadee UI"/>
+        <a:font script="Bopo" typeface="Microsoft JhengHei"/>
+        <a:font script="Java" typeface="Javanese Text"/>
+        <a:font script="Lisu" typeface="Segoe UI"/>
+        <a:font script="Mymr" typeface="Myanmar Text"/>
+        <a:font script="Nkoo" typeface="Ebrima"/>
+        <a:font script="Olck" typeface="Nirmala UI"/>
+        <a:font script="Osma" typeface="Ebrima"/>
+        <a:font script="Phag" typeface="Phagspa"/>
+        <a:font script="Syrn" typeface="Estrangelo Edessa"/>
+        <a:font script="Syrj" typeface="Estrangelo Edessa"/>
+        <a:font script="Syre" typeface="Estrangelo Edessa"/>
+        <a:font script="Sora" typeface="Nirmala UI"/>
+        <a:font script="Tale" typeface="Microsoft Tai Le"/>
+        <a:font script="Talu" typeface="Microsoft New Tai Lue"/>
+        <a:font script="Tfng" typeface="Ebrima"/>
+      </a:majorFont>
+      <a:minorFont>
+        <a:latin typeface="맑은 고딕" panose="02110004020202020204"/>
+        <a:ea typeface=""/>
+        <a:cs typeface=""/>
+        <a:font script="Jpan" typeface="游ゴシック"/>
+        <a:font script="Hang" typeface="맑은 고딕"/>
+        <a:font script="Hans" typeface="等线"/>
+        <a:font script="Hant" typeface="新細明體"/>
+        <a:font script="Arab" typeface="Arial"/>
+        <a:font script="Hebr" typeface="Arial"/>
+        <a:font script="Thai" typeface="Cordia New"/>
+        <a:font script="Ethi" typeface="Nyala"/>
+        <a:font script="Beng" typeface="Vrinda"/>
+        <a:font script="Gujr" typeface="Shruti"/>
+        <a:font script="Khmr" typeface="DaunPenh"/>
+        <a:font script="Knda" typeface="Tunga"/>
+        <a:font script="Guru" typeface="Raavi"/>
+        <a:font script="Cans" typeface="Euphemia"/>
+        <a:font script="Cher" typeface="Plantagenet Cherokee"/>
+        <a:font script="Yiii" typeface="Microsoft Yi Baiti"/>
+        <a:font script="Tibt" typeface="Microsoft Himalaya"/>
+        <a:font script="Thaa" typeface="MV Boli"/>
+        <a:font script="Deva" typeface="Mangal"/>
+        <a:font script="Telu" typeface="Gautami"/>
+        <a:font script="Taml" typeface="Latha"/>
+        <a:font script="Syrc" typeface="Estrangelo Edessa"/>
+        <a:font script="Orya" typeface="Kalinga"/>
+        <a:font script="Mlym" typeface="Kartika"/>
+        <a:font script="Laoo" typeface="DokChampa"/>
+        <a:font script="Sinh" typeface="Iskoola Pota"/>
+        <a:font script="Mong" typeface="Mongolian Baiti"/>
+        <a:font script="Viet" typeface="Arial"/>
+        <a:font script="Uigh" typeface="Microsoft Uighur"/>
+        <a:font script="Geor" typeface="Sylfaen"/>
+        <a:font script="Armn" typeface="Arial"/>
+        <a:font script="Bugi" typeface="Leelawadee UI"/>
+        <a:font script="Bopo" typeface="Microsoft JhengHei"/>
+        <a:font script="Java" typeface="Javanese Text"/>
+        <a:font script="Lisu" typeface="Segoe UI"/>
+        <a:font script="Mymr" typeface="Myanmar Text"/>
+        <a:font script="Nkoo" typeface="Ebrima"/>
+        <a:font script="Olck" typeface="Nirmala UI"/>
+        <a:font script="Osma" typeface="Ebrima"/>
+        <a:font script="Phag" typeface="Phagspa"/>
+        <a:font script="Syrn" typeface="Estrangelo Edessa"/>
+        <a:font script="Syrj" typeface="Estrangelo Edessa"/>
+        <a:font script="Syre" typeface="Estrangelo Edessa"/>
+        <a:font script="Sora" typeface="Nirmala UI"/>
+        <a:font script="Tale" typeface="Microsoft Tai Le"/>
+        <a:font script="Talu" typeface="Microsoft New Tai Lue"/>
+        <a:font script="Tfng" typeface="Ebrima"/>
+      </a:minorFont>
+    </a:fontScheme>
+    <a:fmtScheme name="Office">
+      <a:fillStyleLst>
+        <a:solidFill>
+          <a:schemeClr val="phClr"/>
+        </a:solidFill>
+        <a:gradFill rotWithShape="1">
+          <a:gsLst>
+            <a:gs pos="0">
+              <a:schemeClr val="phClr">
+                <a:lumMod val="110000"/>
+                <a:satMod val="105000"/>
+                <a:tint val="67000"/>
+              </a:schemeClr>
+            </a:gs>
+            <a:gs pos="50000">
+              <a:schemeClr val="phClr">
+                <a:lumMod val="105000"/>
+                <a:satMod val="103000"/>
+                <a:tint val="73000"/>
+              </a:schemeClr>
+            </a:gs>
+            <a:gs pos="100000">
+              <a:schemeClr val="phClr">
+                <a:lumMod val="105000"/>
+                <a:satMod val="109000"/>
+                <a:tint val="81000"/>
+              </a:schemeClr>
+            </a:gs>
+          </a:gsLst>
+          <a:lin ang="5400000" scaled="0"/>
+        </a:gradFill>
+        <a:gradFill rotWithShape="1">
+          <a:gsLst>
+            <a:gs pos="0">
+              <a:schemeClr val="phClr">
+                <a:satMod val="103000"/>
+                <a:lumMod val="102000"/>
+                <a:tint val="94000"/>
+              </a:schemeClr>
+            </a:gs>
+            <a:gs pos="50000">
+              <a:schemeClr val="phClr">
+                <a:satMod val="110000"/>
+                <a:lumMod val="100000"/>
+                <a:shade val="100000"/>
+              </a:schemeClr>
+            </a:gs>
+            <a:gs pos="100000">
+              <a:schemeClr val="phClr">
+                <a:lumMod val="99000"/>
+                <a:satMod val="120000"/>
+                <a:shade val="78000"/>
+              </a:schemeClr>
+            </a:gs>
+          </a:gsLst>
+          <a:lin ang="5400000" scaled="0"/>
+        </a:gradFill>
+      </a:fillStyleLst>
+      <a:lnStyleLst>
+        <a:ln w="12700" cap="flat" cmpd="sng" algn="ctr">
+          <a:solidFill>
+            <a:schemeClr val="phClr"/>
+          </a:solidFill>
+          <a:prstDash val="solid"/>
+          <a:miter lim="800000"/>
+        </a:ln>
+        <a:ln w="19050" cap="flat" cmpd="sng" algn="ctr">
+          <a:solidFill>
+            <a:schemeClr val="phClr"/>
+          </a:solidFill>
+          <a:prstDash val="solid"/>
+          <a:miter lim="800000"/>
+        </a:ln>
+        <a:ln w="25400" cap="flat" cmpd="sng" algn="ctr">
+          <a:solidFill>
+            <a:schemeClr val="phClr"/>
+          </a:solidFill>
+          <a:prstDash val="solid"/>
+          <a:miter lim="800000"/>
+        </a:ln>
+      </a:lnStyleLst>
+      <a:effectStyleLst>
+        <a:effectStyle>
+          <a:effectLst/>
+        </a:effectStyle>
+        <a:effectStyle>
+          <a:effectLst/>
+        </a:effectStyle>
+        <a:effectStyle>
+          <a:effectLst>
+            <a:outerShdw blurRad="57150" dist="19050" dir="5400000" algn="ctr" rotWithShape="0">
+              <a:srgbClr val="000000">
+                <a:alpha val="63000"/>
+              </a:srgbClr>
+            </a:outerShdw>
+          </a:effectLst>
+        </a:effectStyle>
+      </a:effectStyleLst>
+      <a:bgFillStyleLst>
+        <a:solidFill>
+          <a:schemeClr val="phClr"/>
+        </a:solidFill>
+        <a:solidFill>
+          <a:schemeClr val="phClr">
+            <a:tint val="95000"/>
+            <a:satMod val="170000"/>
+          </a:schemeClr>
+        </a:solidFill>
+        <a:gradFill rotWithShape="1">
+          <a:gsLst>
+            <a:gs pos="0">
+              <a:schemeClr val="phClr">
+                <a:tint val="93000"/>
+                <a:satMod val="150000"/>
+                <a:shade val="98000"/>
+                <a:lumMod val="102000"/>
+              </a:schemeClr>
+            </a:gs>
+            <a:gs pos="50000">
+              <a:schemeClr val="phClr">
+                <a:tint val="98000"/>
+                <a:satMod val="130000"/>
+                <a:shade val="90000"/>
+                <a:lumMod val="103000"/>
+              </a:schemeClr>
+            </a:gs>
+            <a:gs pos="100000">
+              <a:schemeClr val="phClr">
+                <a:shade val="63000"/>
+                <a:satMod val="120000"/>
+              </a:schemeClr>
+            </a:gs>
+          </a:gsLst>
+          <a:lin ang="5400000" scaled="0"/>
+        </a:gradFill>
+      </a:bgFillStyleLst>
+    </a:fmtScheme>
+  </a:themeElements>
+  <a:objectDefaults>
+    <a:lnDef>
+      <a:spPr/>
+      <a:bodyPr/>
+      <a:lstStyle/>
+      <a:style>
+        <a:lnRef idx="2">
+          <a:schemeClr val="accent1"/>
+        </a:lnRef>
+        <a:fillRef idx="0">
+          <a:schemeClr val="accent1"/>
+        </a:fillRef>
+        <a:effectRef idx="1">
+          <a:schemeClr val="accent1"/>
+        </a:effectRef>
+        <a:fontRef idx="minor">
+          <a:schemeClr val="tx1"/>
+        </a:fontRef>
+      </a:style>
+    </a:lnDef>
+  </a:objectDefaults>
+  <a:extraClrSchemeLst/>
+  <a:extLst>
+    <a:ext uri="{05A4C25C-085E-4340-85A3-A5531E510DB2}">
+      <thm15:themeFamily xmlns:thm15="http://schemas.microsoft.com/office/thememl/2012/main" name="Office Theme" id="{2E142A2C-CD16-42D6-873A-C26D2A0506FA}" vid="{1BDDFF52-6CD6-40A5-AB3C-68EB2F1E4D0A}"/>
+    </a:ext>
+  </a:extLst>
+</a:theme>
 </file>
</xml_diff>